<commit_message>
Swap order of harsh-words and flattery in 5-type deck
Co-Authored-By: Claude Sonnet 5.5 <noreply@anthropic.com>
Claude-Session: https://claude.ai/code/session_01PE4MjRQoYc3wWk9Len7Wur
</commit_message>
<xml_diff>
--- a/proverbs-speech.pptx
+++ b/proverbs-speech.pptx
@@ -2314,7 +2314,7 @@
                 <a:ea typeface="Malgun Gothic" pitchFamily="34" charset="-122"/>
                 <a:cs typeface="Malgun Gothic" pitchFamily="34" charset="-120"/>
               </a:rPr>
-              <a:t>아첨하는 말</a:t>
+              <a:t>과격한 말과 지나치게 많은 말</a:t>
             </a:r>
             <a:endParaRPr lang="en-US" sz="1500" dirty="0"/>
           </a:p>
@@ -2353,7 +2353,7 @@
                 <a:ea typeface="Malgun Gothic" pitchFamily="34" charset="-122"/>
                 <a:cs typeface="Malgun Gothic" pitchFamily="34" charset="-120"/>
               </a:rPr>
-              <a:t>잠 29:5 · 26:28</a:t>
+              <a:t>잠 15:1 · 10:19</a:t>
             </a:r>
             <a:endParaRPr lang="en-US" sz="1200" dirty="0"/>
           </a:p>
@@ -2478,7 +2478,7 @@
                 <a:ea typeface="Malgun Gothic" pitchFamily="34" charset="-122"/>
                 <a:cs typeface="Malgun Gothic" pitchFamily="34" charset="-120"/>
               </a:rPr>
-              <a:t>과격한 말과 지나치게 많은 말</a:t>
+              <a:t>아첨하는 말</a:t>
             </a:r>
             <a:endParaRPr lang="en-US" sz="1500" dirty="0"/>
           </a:p>
@@ -2517,7 +2517,7 @@
                 <a:ea typeface="Malgun Gothic" pitchFamily="34" charset="-122"/>
                 <a:cs typeface="Malgun Gothic" pitchFamily="34" charset="-120"/>
               </a:rPr>
-              <a:t>잠 15:1 · 10:19</a:t>
+              <a:t>잠 29:5 · 26:28</a:t>
             </a:r>
             <a:endParaRPr lang="en-US" sz="1200" dirty="0"/>
           </a:p>
@@ -4061,7 +4061,7 @@
                 <a:ea typeface="Malgun Gothic" pitchFamily="34" charset="-122"/>
                 <a:cs typeface="Malgun Gothic" pitchFamily="34" charset="-120"/>
               </a:rPr>
-              <a:t>아첨하는 말</a:t>
+              <a:t>과격한 말과 지나치게 많은 말</a:t>
             </a:r>
             <a:endParaRPr lang="en-US" sz="2600" dirty="0"/>
           </a:p>
@@ -4100,7 +4100,7 @@
                 <a:ea typeface="Malgun Gothic" pitchFamily="34" charset="-122"/>
                 <a:cs typeface="Malgun Gothic" pitchFamily="34" charset="-120"/>
               </a:rPr>
-              <a:t>듣기 좋은 말로 상대를 조종하거나 진실을 가리는 말은 결국 상대를 넘어지게 하고 관계를 무너뜨립니다.</a:t>
+              <a:t>거친 말은 분노를 키우고, 말이 많으면 실수가 늘어납니다. 부드러운 대답과 절제된 입술이 지혜입니다.</a:t>
             </a:r>
             <a:endParaRPr lang="en-US" sz="1400" dirty="0"/>
           </a:p>
@@ -4161,7 +4161,7 @@
                 <a:ea typeface="Malgun Gothic" pitchFamily="34" charset="-122"/>
                 <a:cs typeface="Malgun Gothic" pitchFamily="34" charset="-120"/>
               </a:rPr>
-              <a:t>아첨의 그물</a:t>
+              <a:t>과격한 말</a:t>
             </a:r>
             <a:endParaRPr lang="en-US" sz="1200" dirty="0"/>
           </a:p>
@@ -4200,7 +4200,7 @@
                 <a:ea typeface="Malgun Gothic" pitchFamily="34" charset="-122"/>
                 <a:cs typeface="Malgun Gothic" pitchFamily="34" charset="-120"/>
               </a:rPr>
-              <a:t>"이웃에게 아첨하는 것은 그의 발 앞에 그물을 치는 것이니라"</a:t>
+              <a:t>"유순한 대답은 분노를 쉬게 하여도 과격한 말은 노를 격동하느니라"</a:t>
             </a:r>
             <a:endParaRPr lang="en-US" sz="1300" dirty="0"/>
           </a:p>
@@ -4239,7 +4239,7 @@
                 <a:ea typeface="Malgun Gothic" pitchFamily="34" charset="-122"/>
                 <a:cs typeface="Malgun Gothic" pitchFamily="34" charset="-120"/>
               </a:rPr>
-              <a:t>잠언 29:5</a:t>
+              <a:t>잠언 15:1</a:t>
             </a:r>
             <a:endParaRPr lang="en-US" sz="1200" dirty="0"/>
           </a:p>
@@ -4300,7 +4300,7 @@
                 <a:ea typeface="Malgun Gothic" pitchFamily="34" charset="-122"/>
                 <a:cs typeface="Malgun Gothic" pitchFamily="34" charset="-120"/>
               </a:rPr>
-              <a:t>패망</a:t>
+              <a:t>많은 말</a:t>
             </a:r>
             <a:endParaRPr lang="en-US" sz="1200" dirty="0"/>
           </a:p>
@@ -4339,7 +4339,7 @@
                 <a:ea typeface="Malgun Gothic" pitchFamily="34" charset="-122"/>
                 <a:cs typeface="Malgun Gothic" pitchFamily="34" charset="-120"/>
               </a:rPr>
-              <a:t>"거짓말하는 혀는 그 상처 입은 자를 미워하고 아첨하는 입은 패망을 일으키느니라"</a:t>
+              <a:t>"말이 많으면 허물을 면하기 어려우나 그 입술을 제어하는 자는 지혜가 있느니라"</a:t>
             </a:r>
             <a:endParaRPr lang="en-US" sz="1300" dirty="0"/>
           </a:p>
@@ -4378,7 +4378,7 @@
                 <a:ea typeface="Malgun Gothic" pitchFamily="34" charset="-122"/>
                 <a:cs typeface="Malgun Gothic" pitchFamily="34" charset="-120"/>
               </a:rPr>
-              <a:t>잠언 26:28</a:t>
+              <a:t>잠언 10:19</a:t>
             </a:r>
             <a:endParaRPr lang="en-US" sz="1200" dirty="0"/>
           </a:p>
@@ -4508,7 +4508,7 @@
                 <a:ea typeface="Malgun Gothic" pitchFamily="34" charset="-122"/>
                 <a:cs typeface="Malgun Gothic" pitchFamily="34" charset="-120"/>
               </a:rPr>
-              <a:t>과격한 말과 지나치게 많은 말</a:t>
+              <a:t>아첨하는 말</a:t>
             </a:r>
             <a:endParaRPr lang="en-US" sz="2600" dirty="0"/>
           </a:p>
@@ -4547,7 +4547,7 @@
                 <a:ea typeface="Malgun Gothic" pitchFamily="34" charset="-122"/>
                 <a:cs typeface="Malgun Gothic" pitchFamily="34" charset="-120"/>
               </a:rPr>
-              <a:t>거친 말은 분노를 키우고, 말이 많으면 실수가 늘어납니다. 부드러운 대답과 절제된 입술이 지혜입니다.</a:t>
+              <a:t>듣기 좋은 말로 상대를 조종하거나 진실을 가리는 말은 결국 상대를 넘어지게 하고 관계를 무너뜨립니다.</a:t>
             </a:r>
             <a:endParaRPr lang="en-US" sz="1400" dirty="0"/>
           </a:p>
@@ -4608,7 +4608,7 @@
                 <a:ea typeface="Malgun Gothic" pitchFamily="34" charset="-122"/>
                 <a:cs typeface="Malgun Gothic" pitchFamily="34" charset="-120"/>
               </a:rPr>
-              <a:t>과격한 말</a:t>
+              <a:t>아첨의 그물</a:t>
             </a:r>
             <a:endParaRPr lang="en-US" sz="1200" dirty="0"/>
           </a:p>
@@ -4647,7 +4647,7 @@
                 <a:ea typeface="Malgun Gothic" pitchFamily="34" charset="-122"/>
                 <a:cs typeface="Malgun Gothic" pitchFamily="34" charset="-120"/>
               </a:rPr>
-              <a:t>"유순한 대답은 분노를 쉬게 하여도 과격한 말은 노를 격동하느니라"</a:t>
+              <a:t>"이웃에게 아첨하는 것은 그의 발 앞에 그물을 치는 것이니라"</a:t>
             </a:r>
             <a:endParaRPr lang="en-US" sz="1300" dirty="0"/>
           </a:p>
@@ -4686,7 +4686,7 @@
                 <a:ea typeface="Malgun Gothic" pitchFamily="34" charset="-122"/>
                 <a:cs typeface="Malgun Gothic" pitchFamily="34" charset="-120"/>
               </a:rPr>
-              <a:t>잠언 15:1</a:t>
+              <a:t>잠언 29:5</a:t>
             </a:r>
             <a:endParaRPr lang="en-US" sz="1200" dirty="0"/>
           </a:p>
@@ -4747,7 +4747,7 @@
                 <a:ea typeface="Malgun Gothic" pitchFamily="34" charset="-122"/>
                 <a:cs typeface="Malgun Gothic" pitchFamily="34" charset="-120"/>
               </a:rPr>
-              <a:t>많은 말</a:t>
+              <a:t>패망</a:t>
             </a:r>
             <a:endParaRPr lang="en-US" sz="1200" dirty="0"/>
           </a:p>
@@ -4786,7 +4786,7 @@
                 <a:ea typeface="Malgun Gothic" pitchFamily="34" charset="-122"/>
                 <a:cs typeface="Malgun Gothic" pitchFamily="34" charset="-120"/>
               </a:rPr>
-              <a:t>"말이 많으면 허물을 면하기 어려우나 그 입술을 제어하는 자는 지혜가 있느니라"</a:t>
+              <a:t>"거짓말하는 혀는 그 상처 입은 자를 미워하고 아첨하는 입은 패망을 일으키느니라"</a:t>
             </a:r>
             <a:endParaRPr lang="en-US" sz="1300" dirty="0"/>
           </a:p>
@@ -4825,7 +4825,7 @@
                 <a:ea typeface="Malgun Gothic" pitchFamily="34" charset="-122"/>
                 <a:cs typeface="Malgun Gothic" pitchFamily="34" charset="-120"/>
               </a:rPr>
-              <a:t>잠언 10:19</a:t>
+              <a:t>잠언 26:28</a:t>
             </a:r>
             <a:endParaRPr lang="en-US" sz="1200" dirty="0"/>
           </a:p>

</xml_diff>